<commit_message>
fix: improve pptx text wrapping
</commit_message>
<xml_diff>
--- a/artifacts/chamada_verificada_collateral/zictec-chamada-verificada-apresentacao.pptx
+++ b/artifacts/chamada_verificada_collateral/zictec-chamada-verificada-apresentacao.pptx
@@ -3158,8 +3158,8 @@
           <a:noFill/>
         </p:spPr>
         <p:txBody>
-          <a:bodyPr wrap="none" lIns="18288" rIns="18288" tIns="18288" bIns="18288" anchor="t">
-            <a:spAutoFit/>
+          <a:bodyPr wrap="square" lIns="18288" rIns="18288" tIns="18288" bIns="18288" anchor="t">
+            <a:normAutofit/>
           </a:bodyPr>
           <a:lstStyle/>
           <a:p>
@@ -3193,8 +3193,8 @@
           <a:noFill/>
         </p:spPr>
         <p:txBody>
-          <a:bodyPr wrap="none" lIns="18288" rIns="18288" tIns="18288" bIns="18288" anchor="t">
-            <a:spAutoFit/>
+          <a:bodyPr wrap="square" lIns="18288" rIns="18288" tIns="18288" bIns="18288" anchor="t">
+            <a:normAutofit/>
           </a:bodyPr>
           <a:lstStyle/>
           <a:p>
@@ -3252,8 +3252,8 @@
           <a:noFill/>
         </p:spPr>
         <p:txBody>
-          <a:bodyPr wrap="none" lIns="18288" rIns="18288" tIns="18288" bIns="18288" anchor="t">
-            <a:spAutoFit/>
+          <a:bodyPr wrap="square" lIns="18288" rIns="18288" tIns="18288" bIns="18288" anchor="t">
+            <a:normAutofit/>
           </a:bodyPr>
           <a:lstStyle/>
           <a:p>
@@ -3287,8 +3287,8 @@
           <a:noFill/>
         </p:spPr>
         <p:txBody>
-          <a:bodyPr wrap="none" lIns="18288" rIns="18288" tIns="18288" bIns="18288" anchor="t">
-            <a:spAutoFit/>
+          <a:bodyPr wrap="square" lIns="18288" rIns="18288" tIns="18288" bIns="18288" anchor="t">
+            <a:normAutofit/>
           </a:bodyPr>
           <a:lstStyle/>
           <a:p>
@@ -3367,8 +3367,8 @@
           <a:noFill/>
         </p:spPr>
         <p:txBody>
-          <a:bodyPr wrap="none" lIns="18288" rIns="18288" tIns="18288" bIns="18288" anchor="t">
-            <a:spAutoFit/>
+          <a:bodyPr wrap="square" lIns="18288" rIns="18288" tIns="18288" bIns="18288" anchor="t">
+            <a:normAutofit/>
           </a:bodyPr>
           <a:lstStyle/>
           <a:p>
@@ -3402,8 +3402,8 @@
           <a:noFill/>
         </p:spPr>
         <p:txBody>
-          <a:bodyPr wrap="none" lIns="18288" rIns="18288" tIns="18288" bIns="18288" anchor="t">
-            <a:spAutoFit/>
+          <a:bodyPr wrap="square" lIns="18288" rIns="18288" tIns="18288" bIns="18288" anchor="t">
+            <a:normAutofit/>
           </a:bodyPr>
           <a:lstStyle/>
           <a:p>
@@ -3482,8 +3482,8 @@
           <a:noFill/>
         </p:spPr>
         <p:txBody>
-          <a:bodyPr wrap="none" lIns="18288" rIns="18288" tIns="18288" bIns="18288" anchor="t">
-            <a:spAutoFit/>
+          <a:bodyPr wrap="square" lIns="18288" rIns="18288" tIns="18288" bIns="18288" anchor="t">
+            <a:normAutofit/>
           </a:bodyPr>
           <a:lstStyle/>
           <a:p>
@@ -3517,8 +3517,8 @@
           <a:noFill/>
         </p:spPr>
         <p:txBody>
-          <a:bodyPr wrap="none" lIns="18288" rIns="18288" tIns="18288" bIns="18288" anchor="t">
-            <a:spAutoFit/>
+          <a:bodyPr wrap="square" lIns="18288" rIns="18288" tIns="18288" bIns="18288" anchor="t">
+            <a:normAutofit/>
           </a:bodyPr>
           <a:lstStyle/>
           <a:p>
@@ -3597,8 +3597,8 @@
           <a:noFill/>
         </p:spPr>
         <p:txBody>
-          <a:bodyPr wrap="none" lIns="18288" rIns="18288" tIns="18288" bIns="18288" anchor="t">
-            <a:spAutoFit/>
+          <a:bodyPr wrap="square" lIns="18288" rIns="18288" tIns="18288" bIns="18288" anchor="t">
+            <a:normAutofit/>
           </a:bodyPr>
           <a:lstStyle/>
           <a:p>
@@ -3632,8 +3632,8 @@
           <a:noFill/>
         </p:spPr>
         <p:txBody>
-          <a:bodyPr wrap="none" lIns="18288" rIns="18288" tIns="18288" bIns="18288" anchor="t">
-            <a:spAutoFit/>
+          <a:bodyPr wrap="square" lIns="18288" rIns="18288" tIns="18288" bIns="18288" anchor="t">
+            <a:normAutofit/>
           </a:bodyPr>
           <a:lstStyle/>
           <a:p>
@@ -3712,8 +3712,8 @@
           <a:noFill/>
         </p:spPr>
         <p:txBody>
-          <a:bodyPr wrap="none" lIns="18288" rIns="18288" tIns="18288" bIns="18288" anchor="t">
-            <a:spAutoFit/>
+          <a:bodyPr wrap="square" lIns="18288" rIns="18288" tIns="18288" bIns="18288" anchor="t">
+            <a:normAutofit/>
           </a:bodyPr>
           <a:lstStyle/>
           <a:p>
@@ -3747,8 +3747,8 @@
           <a:noFill/>
         </p:spPr>
         <p:txBody>
-          <a:bodyPr wrap="none" lIns="18288" rIns="18288" tIns="18288" bIns="18288" anchor="t">
-            <a:spAutoFit/>
+          <a:bodyPr wrap="square" lIns="18288" rIns="18288" tIns="18288" bIns="18288" anchor="t">
+            <a:normAutofit/>
           </a:bodyPr>
           <a:lstStyle/>
           <a:p>
@@ -3851,8 +3851,8 @@
           <a:noFill/>
         </p:spPr>
         <p:txBody>
-          <a:bodyPr wrap="none" lIns="18288" rIns="18288" tIns="18288" bIns="18288" anchor="t">
-            <a:spAutoFit/>
+          <a:bodyPr wrap="square" lIns="18288" rIns="18288" tIns="18288" bIns="18288" anchor="t">
+            <a:normAutofit/>
           </a:bodyPr>
           <a:lstStyle/>
           <a:p>
@@ -3947,8 +3947,8 @@
           <a:noFill/>
         </p:spPr>
         <p:txBody>
-          <a:bodyPr wrap="none" lIns="18288" rIns="18288" tIns="18288" bIns="18288" anchor="t">
-            <a:spAutoFit/>
+          <a:bodyPr wrap="square" lIns="18288" rIns="18288" tIns="18288" bIns="18288" anchor="t">
+            <a:normAutofit/>
           </a:bodyPr>
           <a:lstStyle/>
           <a:p>
@@ -4006,8 +4006,8 @@
           <a:noFill/>
         </p:spPr>
         <p:txBody>
-          <a:bodyPr wrap="none" lIns="18288" rIns="18288" tIns="18288" bIns="18288" anchor="t">
-            <a:spAutoFit/>
+          <a:bodyPr wrap="square" lIns="18288" rIns="18288" tIns="18288" bIns="18288" anchor="t">
+            <a:normAutofit/>
           </a:bodyPr>
           <a:lstStyle/>
           <a:p>
@@ -4086,8 +4086,8 @@
           <a:noFill/>
         </p:spPr>
         <p:txBody>
-          <a:bodyPr wrap="none" lIns="18288" rIns="18288" tIns="18288" bIns="18288" anchor="t">
-            <a:spAutoFit/>
+          <a:bodyPr wrap="square" lIns="18288" rIns="18288" tIns="18288" bIns="18288" anchor="t">
+            <a:normAutofit/>
           </a:bodyPr>
           <a:lstStyle/>
           <a:p>
@@ -4121,8 +4121,8 @@
           <a:noFill/>
         </p:spPr>
         <p:txBody>
-          <a:bodyPr wrap="none" lIns="18288" rIns="18288" tIns="18288" bIns="18288" anchor="t">
-            <a:spAutoFit/>
+          <a:bodyPr wrap="square" lIns="18288" rIns="18288" tIns="18288" bIns="18288" anchor="t">
+            <a:normAutofit/>
           </a:bodyPr>
           <a:lstStyle/>
           <a:p>
@@ -4201,8 +4201,8 @@
           <a:noFill/>
         </p:spPr>
         <p:txBody>
-          <a:bodyPr wrap="none" lIns="18288" rIns="18288" tIns="18288" bIns="18288" anchor="t">
-            <a:spAutoFit/>
+          <a:bodyPr wrap="square" lIns="18288" rIns="18288" tIns="18288" bIns="18288" anchor="t">
+            <a:normAutofit/>
           </a:bodyPr>
           <a:lstStyle/>
           <a:p>
@@ -4236,8 +4236,8 @@
           <a:noFill/>
         </p:spPr>
         <p:txBody>
-          <a:bodyPr wrap="none" lIns="18288" rIns="18288" tIns="18288" bIns="18288" anchor="t">
-            <a:spAutoFit/>
+          <a:bodyPr wrap="square" lIns="18288" rIns="18288" tIns="18288" bIns="18288" anchor="t">
+            <a:normAutofit/>
           </a:bodyPr>
           <a:lstStyle/>
           <a:p>
@@ -4316,8 +4316,8 @@
           <a:noFill/>
         </p:spPr>
         <p:txBody>
-          <a:bodyPr wrap="none" lIns="18288" rIns="18288" tIns="18288" bIns="18288" anchor="t">
-            <a:spAutoFit/>
+          <a:bodyPr wrap="square" lIns="18288" rIns="18288" tIns="18288" bIns="18288" anchor="t">
+            <a:normAutofit/>
           </a:bodyPr>
           <a:lstStyle/>
           <a:p>
@@ -4351,8 +4351,8 @@
           <a:noFill/>
         </p:spPr>
         <p:txBody>
-          <a:bodyPr wrap="none" lIns="18288" rIns="18288" tIns="18288" bIns="18288" anchor="t">
-            <a:spAutoFit/>
+          <a:bodyPr wrap="square" lIns="18288" rIns="18288" tIns="18288" bIns="18288" anchor="t">
+            <a:normAutofit/>
           </a:bodyPr>
           <a:lstStyle/>
           <a:p>
@@ -4431,8 +4431,8 @@
           <a:noFill/>
         </p:spPr>
         <p:txBody>
-          <a:bodyPr wrap="none" lIns="18288" rIns="18288" tIns="18288" bIns="18288" anchor="t">
-            <a:spAutoFit/>
+          <a:bodyPr wrap="square" lIns="18288" rIns="18288" tIns="18288" bIns="18288" anchor="t">
+            <a:normAutofit/>
           </a:bodyPr>
           <a:lstStyle/>
           <a:p>
@@ -4466,8 +4466,8 @@
           <a:noFill/>
         </p:spPr>
         <p:txBody>
-          <a:bodyPr wrap="none" lIns="18288" rIns="18288" tIns="18288" bIns="18288" anchor="t">
-            <a:spAutoFit/>
+          <a:bodyPr wrap="square" lIns="18288" rIns="18288" tIns="18288" bIns="18288" anchor="t">
+            <a:normAutofit/>
           </a:bodyPr>
           <a:lstStyle/>
           <a:p>
@@ -4562,8 +4562,8 @@
           <a:noFill/>
         </p:spPr>
         <p:txBody>
-          <a:bodyPr wrap="none" lIns="18288" rIns="18288" tIns="18288" bIns="18288" anchor="t">
-            <a:spAutoFit/>
+          <a:bodyPr wrap="square" lIns="18288" rIns="18288" tIns="18288" bIns="18288" anchor="t">
+            <a:normAutofit/>
           </a:bodyPr>
           <a:lstStyle/>
           <a:p>
@@ -4621,8 +4621,8 @@
           <a:noFill/>
         </p:spPr>
         <p:txBody>
-          <a:bodyPr wrap="none" lIns="18288" rIns="18288" tIns="18288" bIns="18288" anchor="t">
-            <a:spAutoFit/>
+          <a:bodyPr wrap="square" lIns="18288" rIns="18288" tIns="18288" bIns="18288" anchor="t">
+            <a:normAutofit/>
           </a:bodyPr>
           <a:lstStyle/>
           <a:p>
@@ -4701,8 +4701,8 @@
           <a:noFill/>
         </p:spPr>
         <p:txBody>
-          <a:bodyPr wrap="none" lIns="18288" rIns="18288" tIns="18288" bIns="18288" anchor="t">
-            <a:spAutoFit/>
+          <a:bodyPr wrap="square" lIns="18288" rIns="18288" tIns="18288" bIns="18288" anchor="t">
+            <a:normAutofit/>
           </a:bodyPr>
           <a:lstStyle/>
           <a:p>
@@ -4736,8 +4736,8 @@
           <a:noFill/>
         </p:spPr>
         <p:txBody>
-          <a:bodyPr wrap="none" lIns="18288" rIns="18288" tIns="18288" bIns="18288" anchor="t">
-            <a:spAutoFit/>
+          <a:bodyPr wrap="square" lIns="18288" rIns="18288" tIns="18288" bIns="18288" anchor="t">
+            <a:normAutofit/>
           </a:bodyPr>
           <a:lstStyle/>
           <a:p>
@@ -4816,8 +4816,8 @@
           <a:noFill/>
         </p:spPr>
         <p:txBody>
-          <a:bodyPr wrap="none" lIns="18288" rIns="18288" tIns="18288" bIns="18288" anchor="t">
-            <a:spAutoFit/>
+          <a:bodyPr wrap="square" lIns="18288" rIns="18288" tIns="18288" bIns="18288" anchor="t">
+            <a:normAutofit/>
           </a:bodyPr>
           <a:lstStyle/>
           <a:p>
@@ -4851,8 +4851,8 @@
           <a:noFill/>
         </p:spPr>
         <p:txBody>
-          <a:bodyPr wrap="none" lIns="18288" rIns="18288" tIns="18288" bIns="18288" anchor="t">
-            <a:spAutoFit/>
+          <a:bodyPr wrap="square" lIns="18288" rIns="18288" tIns="18288" bIns="18288" anchor="t">
+            <a:normAutofit/>
           </a:bodyPr>
           <a:lstStyle/>
           <a:p>
@@ -4931,8 +4931,8 @@
           <a:noFill/>
         </p:spPr>
         <p:txBody>
-          <a:bodyPr wrap="none" lIns="18288" rIns="18288" tIns="18288" bIns="18288" anchor="t">
-            <a:spAutoFit/>
+          <a:bodyPr wrap="square" lIns="18288" rIns="18288" tIns="18288" bIns="18288" anchor="t">
+            <a:normAutofit/>
           </a:bodyPr>
           <a:lstStyle/>
           <a:p>
@@ -4966,8 +4966,8 @@
           <a:noFill/>
         </p:spPr>
         <p:txBody>
-          <a:bodyPr wrap="none" lIns="18288" rIns="18288" tIns="18288" bIns="18288" anchor="t">
-            <a:spAutoFit/>
+          <a:bodyPr wrap="square" lIns="18288" rIns="18288" tIns="18288" bIns="18288" anchor="t">
+            <a:normAutofit/>
           </a:bodyPr>
           <a:lstStyle/>
           <a:p>
@@ -5062,8 +5062,8 @@
           <a:noFill/>
         </p:spPr>
         <p:txBody>
-          <a:bodyPr wrap="none" lIns="18288" rIns="18288" tIns="18288" bIns="18288" anchor="t">
-            <a:spAutoFit/>
+          <a:bodyPr wrap="square" lIns="18288" rIns="18288" tIns="18288" bIns="18288" anchor="t">
+            <a:normAutofit/>
           </a:bodyPr>
           <a:lstStyle/>
           <a:p>
@@ -5121,8 +5121,8 @@
           <a:noFill/>
         </p:spPr>
         <p:txBody>
-          <a:bodyPr wrap="none" lIns="18288" rIns="18288" tIns="18288" bIns="18288" anchor="t">
-            <a:spAutoFit/>
+          <a:bodyPr wrap="square" lIns="18288" rIns="18288" tIns="18288" bIns="18288" anchor="t">
+            <a:normAutofit/>
           </a:bodyPr>
           <a:lstStyle/>
           <a:p>
@@ -5201,8 +5201,8 @@
           <a:noFill/>
         </p:spPr>
         <p:txBody>
-          <a:bodyPr wrap="none" lIns="18288" rIns="18288" tIns="18288" bIns="18288" anchor="t">
-            <a:spAutoFit/>
+          <a:bodyPr wrap="square" lIns="18288" rIns="18288" tIns="18288" bIns="18288" anchor="t">
+            <a:normAutofit/>
           </a:bodyPr>
           <a:lstStyle/>
           <a:p>
@@ -5236,8 +5236,8 @@
           <a:noFill/>
         </p:spPr>
         <p:txBody>
-          <a:bodyPr wrap="none" lIns="18288" rIns="18288" tIns="18288" bIns="18288" anchor="t">
-            <a:spAutoFit/>
+          <a:bodyPr wrap="square" lIns="18288" rIns="18288" tIns="18288" bIns="18288" anchor="t">
+            <a:normAutofit/>
           </a:bodyPr>
           <a:lstStyle/>
           <a:p>
@@ -5316,8 +5316,8 @@
           <a:noFill/>
         </p:spPr>
         <p:txBody>
-          <a:bodyPr wrap="none" lIns="18288" rIns="18288" tIns="18288" bIns="18288" anchor="t">
-            <a:spAutoFit/>
+          <a:bodyPr wrap="square" lIns="18288" rIns="18288" tIns="18288" bIns="18288" anchor="t">
+            <a:normAutofit/>
           </a:bodyPr>
           <a:lstStyle/>
           <a:p>
@@ -5351,8 +5351,8 @@
           <a:noFill/>
         </p:spPr>
         <p:txBody>
-          <a:bodyPr wrap="none" lIns="18288" rIns="18288" tIns="18288" bIns="18288" anchor="t">
-            <a:spAutoFit/>
+          <a:bodyPr wrap="square" lIns="18288" rIns="18288" tIns="18288" bIns="18288" anchor="t">
+            <a:normAutofit/>
           </a:bodyPr>
           <a:lstStyle/>
           <a:p>
@@ -5431,8 +5431,8 @@
           <a:noFill/>
         </p:spPr>
         <p:txBody>
-          <a:bodyPr wrap="none" lIns="18288" rIns="18288" tIns="18288" bIns="18288" anchor="t">
-            <a:spAutoFit/>
+          <a:bodyPr wrap="square" lIns="18288" rIns="18288" tIns="18288" bIns="18288" anchor="t">
+            <a:normAutofit/>
           </a:bodyPr>
           <a:lstStyle/>
           <a:p>
@@ -5466,8 +5466,8 @@
           <a:noFill/>
         </p:spPr>
         <p:txBody>
-          <a:bodyPr wrap="none" lIns="18288" rIns="18288" tIns="18288" bIns="18288" anchor="t">
-            <a:spAutoFit/>
+          <a:bodyPr wrap="square" lIns="18288" rIns="18288" tIns="18288" bIns="18288" anchor="t">
+            <a:normAutofit/>
           </a:bodyPr>
           <a:lstStyle/>
           <a:p>
@@ -5562,8 +5562,8 @@
           <a:noFill/>
         </p:spPr>
         <p:txBody>
-          <a:bodyPr wrap="none" lIns="18288" rIns="18288" tIns="18288" bIns="18288" anchor="t">
-            <a:spAutoFit/>
+          <a:bodyPr wrap="square" lIns="18288" rIns="18288" tIns="18288" bIns="18288" anchor="t">
+            <a:normAutofit/>
           </a:bodyPr>
           <a:lstStyle/>
           <a:p>
@@ -5621,8 +5621,8 @@
           <a:noFill/>
         </p:spPr>
         <p:txBody>
-          <a:bodyPr wrap="none" lIns="18288" rIns="18288" tIns="18288" bIns="18288" anchor="t">
-            <a:spAutoFit/>
+          <a:bodyPr wrap="square" lIns="18288" rIns="18288" tIns="18288" bIns="18288" anchor="t">
+            <a:normAutofit/>
           </a:bodyPr>
           <a:lstStyle/>
           <a:p>
@@ -5701,8 +5701,8 @@
           <a:noFill/>
         </p:spPr>
         <p:txBody>
-          <a:bodyPr wrap="none" lIns="18288" rIns="18288" tIns="18288" bIns="18288" anchor="t">
-            <a:spAutoFit/>
+          <a:bodyPr wrap="square" lIns="18288" rIns="18288" tIns="18288" bIns="18288" anchor="t">
+            <a:normAutofit/>
           </a:bodyPr>
           <a:lstStyle/>
           <a:p>
@@ -5736,8 +5736,8 @@
           <a:noFill/>
         </p:spPr>
         <p:txBody>
-          <a:bodyPr wrap="none" lIns="18288" rIns="18288" tIns="18288" bIns="18288" anchor="t">
-            <a:spAutoFit/>
+          <a:bodyPr wrap="square" lIns="18288" rIns="18288" tIns="18288" bIns="18288" anchor="t">
+            <a:normAutofit/>
           </a:bodyPr>
           <a:lstStyle/>
           <a:p>
@@ -5771,8 +5771,8 @@
           <a:noFill/>
         </p:spPr>
         <p:txBody>
-          <a:bodyPr wrap="none" lIns="18288" rIns="18288" tIns="18288" bIns="18288" anchor="t">
-            <a:spAutoFit/>
+          <a:bodyPr wrap="square" lIns="18288" rIns="18288" tIns="18288" bIns="18288" anchor="t">
+            <a:normAutofit/>
           </a:bodyPr>
           <a:lstStyle/>
           <a:p>
@@ -5806,8 +5806,8 @@
           <a:noFill/>
         </p:spPr>
         <p:txBody>
-          <a:bodyPr wrap="none" lIns="18288" rIns="18288" tIns="18288" bIns="18288" anchor="t">
-            <a:spAutoFit/>
+          <a:bodyPr wrap="square" lIns="18288" rIns="18288" tIns="18288" bIns="18288" anchor="t">
+            <a:normAutofit/>
           </a:bodyPr>
           <a:lstStyle/>
           <a:p>
@@ -5886,8 +5886,8 @@
           <a:noFill/>
         </p:spPr>
         <p:txBody>
-          <a:bodyPr wrap="none" lIns="18288" rIns="18288" tIns="18288" bIns="18288" anchor="t">
-            <a:spAutoFit/>
+          <a:bodyPr wrap="square" lIns="18288" rIns="18288" tIns="18288" bIns="18288" anchor="t">
+            <a:normAutofit/>
           </a:bodyPr>
           <a:lstStyle/>
           <a:p>
@@ -5921,8 +5921,8 @@
           <a:noFill/>
         </p:spPr>
         <p:txBody>
-          <a:bodyPr wrap="none" lIns="18288" rIns="18288" tIns="18288" bIns="18288" anchor="t">
-            <a:spAutoFit/>
+          <a:bodyPr wrap="square" lIns="18288" rIns="18288" tIns="18288" bIns="18288" anchor="t">
+            <a:normAutofit/>
           </a:bodyPr>
           <a:lstStyle/>
           <a:p>
@@ -5956,8 +5956,8 @@
           <a:noFill/>
         </p:spPr>
         <p:txBody>
-          <a:bodyPr wrap="none" lIns="18288" rIns="18288" tIns="18288" bIns="18288" anchor="t">
-            <a:spAutoFit/>
+          <a:bodyPr wrap="square" lIns="18288" rIns="18288" tIns="18288" bIns="18288" anchor="t">
+            <a:normAutofit/>
           </a:bodyPr>
           <a:lstStyle/>
           <a:p>
@@ -5991,8 +5991,8 @@
           <a:noFill/>
         </p:spPr>
         <p:txBody>
-          <a:bodyPr wrap="none" lIns="18288" rIns="18288" tIns="18288" bIns="18288" anchor="t">
-            <a:spAutoFit/>
+          <a:bodyPr wrap="square" lIns="18288" rIns="18288" tIns="18288" bIns="18288" anchor="t">
+            <a:normAutofit/>
           </a:bodyPr>
           <a:lstStyle/>
           <a:p>
@@ -6071,8 +6071,8 @@
           <a:noFill/>
         </p:spPr>
         <p:txBody>
-          <a:bodyPr wrap="none" lIns="18288" rIns="18288" tIns="18288" bIns="18288" anchor="t">
-            <a:spAutoFit/>
+          <a:bodyPr wrap="square" lIns="18288" rIns="18288" tIns="18288" bIns="18288" anchor="t">
+            <a:normAutofit/>
           </a:bodyPr>
           <a:lstStyle/>
           <a:p>
@@ -6106,8 +6106,8 @@
           <a:noFill/>
         </p:spPr>
         <p:txBody>
-          <a:bodyPr wrap="none" lIns="18288" rIns="18288" tIns="18288" bIns="18288" anchor="t">
-            <a:spAutoFit/>
+          <a:bodyPr wrap="square" lIns="18288" rIns="18288" tIns="18288" bIns="18288" anchor="t">
+            <a:normAutofit/>
           </a:bodyPr>
           <a:lstStyle/>
           <a:p>
@@ -6141,8 +6141,8 @@
           <a:noFill/>
         </p:spPr>
         <p:txBody>
-          <a:bodyPr wrap="none" lIns="18288" rIns="18288" tIns="18288" bIns="18288" anchor="t">
-            <a:spAutoFit/>
+          <a:bodyPr wrap="square" lIns="18288" rIns="18288" tIns="18288" bIns="18288" anchor="t">
+            <a:normAutofit/>
           </a:bodyPr>
           <a:lstStyle/>
           <a:p>
@@ -6221,8 +6221,8 @@
           <a:noFill/>
         </p:spPr>
         <p:txBody>
-          <a:bodyPr wrap="none" lIns="18288" rIns="18288" tIns="18288" bIns="18288" anchor="t">
-            <a:spAutoFit/>
+          <a:bodyPr wrap="square" lIns="18288" rIns="18288" tIns="18288" bIns="18288" anchor="t">
+            <a:normAutofit/>
           </a:bodyPr>
           <a:lstStyle/>
           <a:p>
@@ -6317,8 +6317,8 @@
           <a:noFill/>
         </p:spPr>
         <p:txBody>
-          <a:bodyPr wrap="none" lIns="18288" rIns="18288" tIns="18288" bIns="18288" anchor="t">
-            <a:spAutoFit/>
+          <a:bodyPr wrap="square" lIns="18288" rIns="18288" tIns="18288" bIns="18288" anchor="t">
+            <a:normAutofit/>
           </a:bodyPr>
           <a:lstStyle/>
           <a:p>
@@ -6376,8 +6376,8 @@
           <a:noFill/>
         </p:spPr>
         <p:txBody>
-          <a:bodyPr wrap="none" lIns="18288" rIns="18288" tIns="18288" bIns="18288" anchor="t">
-            <a:spAutoFit/>
+          <a:bodyPr wrap="square" lIns="18288" rIns="18288" tIns="18288" bIns="18288" anchor="t">
+            <a:normAutofit/>
           </a:bodyPr>
           <a:lstStyle/>
           <a:p>
@@ -6480,8 +6480,8 @@
           <a:noFill/>
         </p:spPr>
         <p:txBody>
-          <a:bodyPr wrap="none" lIns="18288" rIns="18288" tIns="18288" bIns="18288" anchor="t">
-            <a:spAutoFit/>
+          <a:bodyPr wrap="square" lIns="18288" rIns="18288" tIns="18288" bIns="18288" anchor="t">
+            <a:normAutofit/>
           </a:bodyPr>
           <a:lstStyle/>
           <a:p>
@@ -6515,8 +6515,8 @@
           <a:noFill/>
         </p:spPr>
         <p:txBody>
-          <a:bodyPr wrap="none" lIns="18288" rIns="18288" tIns="18288" bIns="18288" anchor="t">
-            <a:spAutoFit/>
+          <a:bodyPr wrap="square" lIns="18288" rIns="18288" tIns="18288" bIns="18288" anchor="t">
+            <a:normAutofit/>
           </a:bodyPr>
           <a:lstStyle/>
           <a:p>
@@ -6550,8 +6550,8 @@
           <a:noFill/>
         </p:spPr>
         <p:txBody>
-          <a:bodyPr wrap="none" lIns="18288" rIns="18288" tIns="18288" bIns="18288" anchor="t">
-            <a:spAutoFit/>
+          <a:bodyPr wrap="square" lIns="18288" rIns="18288" tIns="18288" bIns="18288" anchor="t">
+            <a:normAutofit/>
           </a:bodyPr>
           <a:lstStyle/>
           <a:p>
@@ -6654,8 +6654,8 @@
           <a:noFill/>
         </p:spPr>
         <p:txBody>
-          <a:bodyPr wrap="none" lIns="18288" rIns="18288" tIns="18288" bIns="18288" anchor="t">
-            <a:spAutoFit/>
+          <a:bodyPr wrap="square" lIns="18288" rIns="18288" tIns="18288" bIns="18288" anchor="t">
+            <a:normAutofit/>
           </a:bodyPr>
           <a:lstStyle/>
           <a:p>
@@ -6689,8 +6689,8 @@
           <a:noFill/>
         </p:spPr>
         <p:txBody>
-          <a:bodyPr wrap="none" lIns="18288" rIns="18288" tIns="18288" bIns="18288" anchor="t">
-            <a:spAutoFit/>
+          <a:bodyPr wrap="square" lIns="18288" rIns="18288" tIns="18288" bIns="18288" anchor="t">
+            <a:normAutofit/>
           </a:bodyPr>
           <a:lstStyle/>
           <a:p>
@@ -6724,8 +6724,8 @@
           <a:noFill/>
         </p:spPr>
         <p:txBody>
-          <a:bodyPr wrap="none" lIns="18288" rIns="18288" tIns="18288" bIns="18288" anchor="t">
-            <a:spAutoFit/>
+          <a:bodyPr wrap="square" lIns="18288" rIns="18288" tIns="18288" bIns="18288" anchor="t">
+            <a:normAutofit/>
           </a:bodyPr>
           <a:lstStyle/>
           <a:p>
@@ -6828,8 +6828,8 @@
           <a:noFill/>
         </p:spPr>
         <p:txBody>
-          <a:bodyPr wrap="none" lIns="18288" rIns="18288" tIns="18288" bIns="18288" anchor="t">
-            <a:spAutoFit/>
+          <a:bodyPr wrap="square" lIns="18288" rIns="18288" tIns="18288" bIns="18288" anchor="t">
+            <a:normAutofit/>
           </a:bodyPr>
           <a:lstStyle/>
           <a:p>
@@ -6863,8 +6863,8 @@
           <a:noFill/>
         </p:spPr>
         <p:txBody>
-          <a:bodyPr wrap="none" lIns="18288" rIns="18288" tIns="18288" bIns="18288" anchor="t">
-            <a:spAutoFit/>
+          <a:bodyPr wrap="square" lIns="18288" rIns="18288" tIns="18288" bIns="18288" anchor="t">
+            <a:normAutofit/>
           </a:bodyPr>
           <a:lstStyle/>
           <a:p>
@@ -6898,8 +6898,8 @@
           <a:noFill/>
         </p:spPr>
         <p:txBody>
-          <a:bodyPr wrap="none" lIns="18288" rIns="18288" tIns="18288" bIns="18288" anchor="t">
-            <a:spAutoFit/>
+          <a:bodyPr wrap="square" lIns="18288" rIns="18288" tIns="18288" bIns="18288" anchor="t">
+            <a:normAutofit/>
           </a:bodyPr>
           <a:lstStyle/>
           <a:p>
@@ -7002,8 +7002,8 @@
           <a:noFill/>
         </p:spPr>
         <p:txBody>
-          <a:bodyPr wrap="none" lIns="18288" rIns="18288" tIns="18288" bIns="18288" anchor="t">
-            <a:spAutoFit/>
+          <a:bodyPr wrap="square" lIns="18288" rIns="18288" tIns="18288" bIns="18288" anchor="t">
+            <a:normAutofit/>
           </a:bodyPr>
           <a:lstStyle/>
           <a:p>
@@ -7037,8 +7037,8 @@
           <a:noFill/>
         </p:spPr>
         <p:txBody>
-          <a:bodyPr wrap="none" lIns="18288" rIns="18288" tIns="18288" bIns="18288" anchor="t">
-            <a:spAutoFit/>
+          <a:bodyPr wrap="square" lIns="18288" rIns="18288" tIns="18288" bIns="18288" anchor="t">
+            <a:normAutofit/>
           </a:bodyPr>
           <a:lstStyle/>
           <a:p>
@@ -7072,8 +7072,8 @@
           <a:noFill/>
         </p:spPr>
         <p:txBody>
-          <a:bodyPr wrap="none" lIns="18288" rIns="18288" tIns="18288" bIns="18288" anchor="t">
-            <a:spAutoFit/>
+          <a:bodyPr wrap="square" lIns="18288" rIns="18288" tIns="18288" bIns="18288" anchor="t">
+            <a:normAutofit/>
           </a:bodyPr>
           <a:lstStyle/>
           <a:p>
@@ -7168,8 +7168,8 @@
           <a:noFill/>
         </p:spPr>
         <p:txBody>
-          <a:bodyPr wrap="none" lIns="18288" rIns="18288" tIns="18288" bIns="18288" anchor="t">
-            <a:spAutoFit/>
+          <a:bodyPr wrap="square" lIns="18288" rIns="18288" tIns="18288" bIns="18288" anchor="t">
+            <a:normAutofit/>
           </a:bodyPr>
           <a:lstStyle/>
           <a:p>
@@ -7227,8 +7227,8 @@
           <a:noFill/>
         </p:spPr>
         <p:txBody>
-          <a:bodyPr wrap="none" lIns="18288" rIns="18288" tIns="18288" bIns="18288" anchor="t">
-            <a:spAutoFit/>
+          <a:bodyPr wrap="square" lIns="18288" rIns="18288" tIns="18288" bIns="18288" anchor="t">
+            <a:normAutofit/>
           </a:bodyPr>
           <a:lstStyle/>
           <a:p>
@@ -7307,8 +7307,8 @@
           <a:noFill/>
         </p:spPr>
         <p:txBody>
-          <a:bodyPr wrap="none" lIns="18288" rIns="18288" tIns="18288" bIns="18288" anchor="t">
-            <a:spAutoFit/>
+          <a:bodyPr wrap="square" lIns="18288" rIns="18288" tIns="18288" bIns="18288" anchor="t">
+            <a:normAutofit/>
           </a:bodyPr>
           <a:lstStyle/>
           <a:p>
@@ -7342,8 +7342,8 @@
           <a:noFill/>
         </p:spPr>
         <p:txBody>
-          <a:bodyPr wrap="none" lIns="18288" rIns="18288" tIns="18288" bIns="18288" anchor="t">
-            <a:spAutoFit/>
+          <a:bodyPr wrap="square" lIns="18288" rIns="18288" tIns="18288" bIns="18288" anchor="t">
+            <a:normAutofit/>
           </a:bodyPr>
           <a:lstStyle/>
           <a:p>
@@ -7422,8 +7422,8 @@
           <a:noFill/>
         </p:spPr>
         <p:txBody>
-          <a:bodyPr wrap="none" lIns="18288" rIns="18288" tIns="18288" bIns="18288" anchor="t">
-            <a:spAutoFit/>
+          <a:bodyPr wrap="square" lIns="18288" rIns="18288" tIns="18288" bIns="18288" anchor="t">
+            <a:normAutofit/>
           </a:bodyPr>
           <a:lstStyle/>
           <a:p>
@@ -7457,8 +7457,8 @@
           <a:noFill/>
         </p:spPr>
         <p:txBody>
-          <a:bodyPr wrap="none" lIns="18288" rIns="18288" tIns="18288" bIns="18288" anchor="t">
-            <a:spAutoFit/>
+          <a:bodyPr wrap="square" lIns="18288" rIns="18288" tIns="18288" bIns="18288" anchor="t">
+            <a:normAutofit/>
           </a:bodyPr>
           <a:lstStyle/>
           <a:p>
@@ -7537,8 +7537,8 @@
           <a:noFill/>
         </p:spPr>
         <p:txBody>
-          <a:bodyPr wrap="none" lIns="18288" rIns="18288" tIns="18288" bIns="18288" anchor="t">
-            <a:spAutoFit/>
+          <a:bodyPr wrap="square" lIns="18288" rIns="18288" tIns="18288" bIns="18288" anchor="t">
+            <a:normAutofit/>
           </a:bodyPr>
           <a:lstStyle/>
           <a:p>
@@ -7572,8 +7572,8 @@
           <a:noFill/>
         </p:spPr>
         <p:txBody>
-          <a:bodyPr wrap="none" lIns="18288" rIns="18288" tIns="18288" bIns="18288" anchor="t">
-            <a:spAutoFit/>
+          <a:bodyPr wrap="square" lIns="18288" rIns="18288" tIns="18288" bIns="18288" anchor="t">
+            <a:normAutofit/>
           </a:bodyPr>
           <a:lstStyle/>
           <a:p>
@@ -7652,8 +7652,8 @@
           <a:noFill/>
         </p:spPr>
         <p:txBody>
-          <a:bodyPr wrap="none" lIns="18288" rIns="18288" tIns="18288" bIns="18288" anchor="t">
-            <a:spAutoFit/>
+          <a:bodyPr wrap="square" lIns="18288" rIns="18288" tIns="18288" bIns="18288" anchor="t">
+            <a:normAutofit/>
           </a:bodyPr>
           <a:lstStyle/>
           <a:p>
@@ -7687,8 +7687,8 @@
           <a:noFill/>
         </p:spPr>
         <p:txBody>
-          <a:bodyPr wrap="none" lIns="18288" rIns="18288" tIns="18288" bIns="18288" anchor="t">
-            <a:spAutoFit/>
+          <a:bodyPr wrap="square" lIns="18288" rIns="18288" tIns="18288" bIns="18288" anchor="t">
+            <a:normAutofit/>
           </a:bodyPr>
           <a:lstStyle/>
           <a:p>
@@ -7767,8 +7767,8 @@
           <a:noFill/>
         </p:spPr>
         <p:txBody>
-          <a:bodyPr wrap="none" lIns="18288" rIns="18288" tIns="18288" bIns="18288" anchor="t">
-            <a:spAutoFit/>
+          <a:bodyPr wrap="square" lIns="18288" rIns="18288" tIns="18288" bIns="18288" anchor="t">
+            <a:normAutofit/>
           </a:bodyPr>
           <a:lstStyle/>
           <a:p>
@@ -7802,8 +7802,8 @@
           <a:noFill/>
         </p:spPr>
         <p:txBody>
-          <a:bodyPr wrap="none" lIns="18288" rIns="18288" tIns="18288" bIns="18288" anchor="t">
-            <a:spAutoFit/>
+          <a:bodyPr wrap="square" lIns="18288" rIns="18288" tIns="18288" bIns="18288" anchor="t">
+            <a:normAutofit/>
           </a:bodyPr>
           <a:lstStyle/>
           <a:p>
@@ -7882,8 +7882,8 @@
           <a:noFill/>
         </p:spPr>
         <p:txBody>
-          <a:bodyPr wrap="none" lIns="18288" rIns="18288" tIns="18288" bIns="18288" anchor="t">
-            <a:spAutoFit/>
+          <a:bodyPr wrap="square" lIns="18288" rIns="18288" tIns="18288" bIns="18288" anchor="t">
+            <a:normAutofit/>
           </a:bodyPr>
           <a:lstStyle/>
           <a:p>
@@ -7917,8 +7917,8 @@
           <a:noFill/>
         </p:spPr>
         <p:txBody>
-          <a:bodyPr wrap="none" lIns="18288" rIns="18288" tIns="18288" bIns="18288" anchor="t">
-            <a:spAutoFit/>
+          <a:bodyPr wrap="square" lIns="18288" rIns="18288" tIns="18288" bIns="18288" anchor="t">
+            <a:normAutofit/>
           </a:bodyPr>
           <a:lstStyle/>
           <a:p>
@@ -8013,8 +8013,8 @@
           <a:noFill/>
         </p:spPr>
         <p:txBody>
-          <a:bodyPr wrap="none" lIns="18288" rIns="18288" tIns="18288" bIns="18288" anchor="t">
-            <a:spAutoFit/>
+          <a:bodyPr wrap="square" lIns="18288" rIns="18288" tIns="18288" bIns="18288" anchor="t">
+            <a:normAutofit/>
           </a:bodyPr>
           <a:lstStyle/>
           <a:p>
@@ -8072,8 +8072,8 @@
           <a:noFill/>
         </p:spPr>
         <p:txBody>
-          <a:bodyPr wrap="none" lIns="18288" rIns="18288" tIns="18288" bIns="18288" anchor="t">
-            <a:spAutoFit/>
+          <a:bodyPr wrap="square" lIns="18288" rIns="18288" tIns="18288" bIns="18288" anchor="t">
+            <a:normAutofit/>
           </a:bodyPr>
           <a:lstStyle/>
           <a:p>
@@ -8206,12 +8206,22 @@
                     <a:lstStyle/>
                     <a:p>
                       <a:r>
-                        <a:rPr sz="919" b="1">
+                        <a:rPr sz="819" b="1">
                           <a:solidFill>
                             <a:srgbClr val="FF5A1F"/>
                           </a:solidFill>
                         </a:rPr>
-                        <a:t>SAAS_STIAS_OOB_A</a:t>
+                        <a:t>SAAS_STIAS_</a:t>
+                      </a:r>
+                    </a:p>
+                    <a:p>
+                      <a:r>
+                        <a:rPr sz="819" b="1">
+                          <a:solidFill>
+                            <a:srgbClr val="FF5A1F"/>
+                          </a:solidFill>
+                        </a:rPr>
+                        <a:t>OOB_A</a:t>
                       </a:r>
                     </a:p>
                   </a:txBody>
@@ -8271,12 +8281,22 @@
                     <a:lstStyle/>
                     <a:p>
                       <a:r>
-                        <a:rPr sz="919" b="1">
+                        <a:rPr sz="819" b="1">
                           <a:solidFill>
                             <a:srgbClr val="FF5A1F"/>
                           </a:solidFill>
                         </a:rPr>
-                        <a:t>ZT_STIAS_API_A</a:t>
+                        <a:t>ZT_STIAS_</a:t>
+                      </a:r>
+                    </a:p>
+                    <a:p>
+                      <a:r>
+                        <a:rPr sz="819" b="1">
+                          <a:solidFill>
+                            <a:srgbClr val="FF5A1F"/>
+                          </a:solidFill>
+                        </a:rPr>
+                        <a:t>API_A</a:t>
                       </a:r>
                     </a:p>
                   </a:txBody>
@@ -8336,12 +8356,22 @@
                     <a:lstStyle/>
                     <a:p>
                       <a:r>
-                        <a:rPr sz="919" b="1">
+                        <a:rPr sz="819" b="1">
                           <a:solidFill>
                             <a:srgbClr val="FF5A1F"/>
                           </a:solidFill>
                         </a:rPr>
-                        <a:t>ZT_STIAS_PROSBC_CLIENT_A</a:t>
+                        <a:t>ZT_STIAS_PROSBC_</a:t>
+                      </a:r>
+                    </a:p>
+                    <a:p>
+                      <a:r>
+                        <a:rPr sz="819" b="1">
+                          <a:solidFill>
+                            <a:srgbClr val="FF5A1F"/>
+                          </a:solidFill>
+                        </a:rPr>
+                        <a:t>CLIENT_A</a:t>
                       </a:r>
                     </a:p>
                   </a:txBody>
@@ -8401,12 +8431,22 @@
                     <a:lstStyle/>
                     <a:p>
                       <a:r>
-                        <a:rPr sz="919" b="1">
+                        <a:rPr sz="819" b="1">
                           <a:solidFill>
                             <a:srgbClr val="FF5A1F"/>
                           </a:solidFill>
                         </a:rPr>
-                        <a:t>ZT_STIAS_PROSBC_SETUP_CLIENT_A</a:t>
+                        <a:t>ZT_STIAS_PROSBC_</a:t>
+                      </a:r>
+                    </a:p>
+                    <a:p>
+                      <a:r>
+                        <a:rPr sz="819" b="1">
+                          <a:solidFill>
+                            <a:srgbClr val="FF5A1F"/>
+                          </a:solidFill>
+                        </a:rPr>
+                        <a:t>SETUP_CLIENT_A</a:t>
                       </a:r>
                     </a:p>
                   </a:txBody>
@@ -8466,12 +8506,22 @@
                     <a:lstStyle/>
                     <a:p>
                       <a:r>
-                        <a:rPr sz="919" b="1">
+                        <a:rPr sz="819" b="1">
                           <a:solidFill>
                             <a:srgbClr val="FF5A1F"/>
                           </a:solidFill>
                         </a:rPr>
-                        <a:t>ZT_PROSBC_HW500_STIAS_SETUP_CLIENT_A</a:t>
+                        <a:t>ZT_PROSBC_HW500_</a:t>
+                      </a:r>
+                    </a:p>
+                    <a:p>
+                      <a:r>
+                        <a:rPr sz="819" b="1">
+                          <a:solidFill>
+                            <a:srgbClr val="FF5A1F"/>
+                          </a:solidFill>
+                        </a:rPr>
+                        <a:t>STIAS_SETUP_CLIENT_A</a:t>
                       </a:r>
                     </a:p>
                   </a:txBody>
@@ -8531,12 +8581,22 @@
                     <a:lstStyle/>
                     <a:p>
                       <a:r>
-                        <a:rPr sz="919" b="1">
+                        <a:rPr sz="819" b="1">
                           <a:solidFill>
                             <a:srgbClr val="FF5A1F"/>
                           </a:solidFill>
                         </a:rPr>
-                        <a:t>ZT_PROSBC_HW500_STIAS_HYBRID_API_A</a:t>
+                        <a:t>ZT_PROSBC_HW500_</a:t>
+                      </a:r>
+                    </a:p>
+                    <a:p>
+                      <a:r>
+                        <a:rPr sz="819" b="1">
+                          <a:solidFill>
+                            <a:srgbClr val="FF5A1F"/>
+                          </a:solidFill>
+                        </a:rPr>
+                        <a:t>STIAS_HYBRID_API_A</a:t>
                       </a:r>
                     </a:p>
                   </a:txBody>
@@ -8650,8 +8710,8 @@
           <a:noFill/>
         </p:spPr>
         <p:txBody>
-          <a:bodyPr wrap="none" lIns="18288" rIns="18288" tIns="18288" bIns="18288" anchor="t">
-            <a:spAutoFit/>
+          <a:bodyPr wrap="square" lIns="18288" rIns="18288" tIns="18288" bIns="18288" anchor="t">
+            <a:normAutofit/>
           </a:bodyPr>
           <a:lstStyle/>
           <a:p>
@@ -8709,8 +8769,8 @@
           <a:noFill/>
         </p:spPr>
         <p:txBody>
-          <a:bodyPr wrap="none" lIns="18288" rIns="18288" tIns="18288" bIns="18288" anchor="t">
-            <a:spAutoFit/>
+          <a:bodyPr wrap="square" lIns="18288" rIns="18288" tIns="18288" bIns="18288" anchor="t">
+            <a:normAutofit/>
           </a:bodyPr>
           <a:lstStyle/>
           <a:p>
@@ -8789,8 +8849,8 @@
           <a:noFill/>
         </p:spPr>
         <p:txBody>
-          <a:bodyPr wrap="none" lIns="18288" rIns="18288" tIns="18288" bIns="18288" anchor="t">
-            <a:spAutoFit/>
+          <a:bodyPr wrap="square" lIns="18288" rIns="18288" tIns="18288" bIns="18288" anchor="t">
+            <a:normAutofit/>
           </a:bodyPr>
           <a:lstStyle/>
           <a:p>
@@ -8824,8 +8884,8 @@
           <a:noFill/>
         </p:spPr>
         <p:txBody>
-          <a:bodyPr wrap="none" lIns="18288" rIns="18288" tIns="18288" bIns="18288" anchor="t">
-            <a:spAutoFit/>
+          <a:bodyPr wrap="square" lIns="18288" rIns="18288" tIns="18288" bIns="18288" anchor="t">
+            <a:normAutofit/>
           </a:bodyPr>
           <a:lstStyle/>
           <a:p>
@@ -8904,8 +8964,8 @@
           <a:noFill/>
         </p:spPr>
         <p:txBody>
-          <a:bodyPr wrap="none" lIns="18288" rIns="18288" tIns="18288" bIns="18288" anchor="t">
-            <a:spAutoFit/>
+          <a:bodyPr wrap="square" lIns="18288" rIns="18288" tIns="18288" bIns="18288" anchor="t">
+            <a:normAutofit/>
           </a:bodyPr>
           <a:lstStyle/>
           <a:p>
@@ -8939,8 +8999,8 @@
           <a:noFill/>
         </p:spPr>
         <p:txBody>
-          <a:bodyPr wrap="none" lIns="18288" rIns="18288" tIns="18288" bIns="18288" anchor="t">
-            <a:spAutoFit/>
+          <a:bodyPr wrap="square" lIns="18288" rIns="18288" tIns="18288" bIns="18288" anchor="t">
+            <a:normAutofit/>
           </a:bodyPr>
           <a:lstStyle/>
           <a:p>
@@ -9019,8 +9079,8 @@
           <a:noFill/>
         </p:spPr>
         <p:txBody>
-          <a:bodyPr wrap="none" lIns="18288" rIns="18288" tIns="18288" bIns="18288" anchor="t">
-            <a:spAutoFit/>
+          <a:bodyPr wrap="square" lIns="18288" rIns="18288" tIns="18288" bIns="18288" anchor="t">
+            <a:normAutofit/>
           </a:bodyPr>
           <a:lstStyle/>
           <a:p>
@@ -9054,8 +9114,8 @@
           <a:noFill/>
         </p:spPr>
         <p:txBody>
-          <a:bodyPr wrap="none" lIns="18288" rIns="18288" tIns="18288" bIns="18288" anchor="t">
-            <a:spAutoFit/>
+          <a:bodyPr wrap="square" lIns="18288" rIns="18288" tIns="18288" bIns="18288" anchor="t">
+            <a:normAutofit/>
           </a:bodyPr>
           <a:lstStyle/>
           <a:p>
@@ -9134,8 +9194,8 @@
           <a:noFill/>
         </p:spPr>
         <p:txBody>
-          <a:bodyPr wrap="none" lIns="18288" rIns="18288" tIns="18288" bIns="18288" anchor="t">
-            <a:spAutoFit/>
+          <a:bodyPr wrap="square" lIns="18288" rIns="18288" tIns="18288" bIns="18288" anchor="t">
+            <a:normAutofit/>
           </a:bodyPr>
           <a:lstStyle/>
           <a:p>
@@ -9169,8 +9229,8 @@
           <a:noFill/>
         </p:spPr>
         <p:txBody>
-          <a:bodyPr wrap="none" lIns="18288" rIns="18288" tIns="18288" bIns="18288" anchor="t">
-            <a:spAutoFit/>
+          <a:bodyPr wrap="square" lIns="18288" rIns="18288" tIns="18288" bIns="18288" anchor="t">
+            <a:normAutofit/>
           </a:bodyPr>
           <a:lstStyle/>
           <a:p>
@@ -9249,8 +9309,8 @@
           <a:noFill/>
         </p:spPr>
         <p:txBody>
-          <a:bodyPr wrap="none" lIns="18288" rIns="18288" tIns="18288" bIns="18288" anchor="t">
-            <a:spAutoFit/>
+          <a:bodyPr wrap="square" lIns="18288" rIns="18288" tIns="18288" bIns="18288" anchor="t">
+            <a:normAutofit/>
           </a:bodyPr>
           <a:lstStyle/>
           <a:p>
@@ -9284,8 +9344,8 @@
           <a:noFill/>
         </p:spPr>
         <p:txBody>
-          <a:bodyPr wrap="none" lIns="18288" rIns="18288" tIns="18288" bIns="18288" anchor="t">
-            <a:spAutoFit/>
+          <a:bodyPr wrap="square" lIns="18288" rIns="18288" tIns="18288" bIns="18288" anchor="t">
+            <a:normAutofit/>
           </a:bodyPr>
           <a:lstStyle/>
           <a:p>
@@ -9404,8 +9464,8 @@
           <a:noFill/>
         </p:spPr>
         <p:txBody>
-          <a:bodyPr wrap="none" lIns="18288" rIns="18288" tIns="18288" bIns="18288" anchor="t">
-            <a:spAutoFit/>
+          <a:bodyPr wrap="square" lIns="18288" rIns="18288" tIns="18288" bIns="18288" anchor="t">
+            <a:normAutofit/>
           </a:bodyPr>
           <a:lstStyle/>
           <a:p>
@@ -9463,8 +9523,8 @@
           <a:noFill/>
         </p:spPr>
         <p:txBody>
-          <a:bodyPr wrap="none" lIns="18288" rIns="18288" tIns="18288" bIns="18288" anchor="t">
-            <a:spAutoFit/>
+          <a:bodyPr wrap="square" lIns="18288" rIns="18288" tIns="18288" bIns="18288" anchor="t">
+            <a:normAutofit/>
           </a:bodyPr>
           <a:lstStyle/>
           <a:p>
@@ -9543,8 +9603,8 @@
           <a:noFill/>
         </p:spPr>
         <p:txBody>
-          <a:bodyPr wrap="none" lIns="18288" rIns="18288" tIns="18288" bIns="18288" anchor="t">
-            <a:spAutoFit/>
+          <a:bodyPr wrap="square" lIns="18288" rIns="18288" tIns="18288" bIns="18288" anchor="t">
+            <a:normAutofit/>
           </a:bodyPr>
           <a:lstStyle/>
           <a:p>
@@ -9578,8 +9638,8 @@
           <a:noFill/>
         </p:spPr>
         <p:txBody>
-          <a:bodyPr wrap="none" lIns="18288" rIns="18288" tIns="18288" bIns="18288" anchor="t">
-            <a:spAutoFit/>
+          <a:bodyPr wrap="square" lIns="18288" rIns="18288" tIns="18288" bIns="18288" anchor="t">
+            <a:normAutofit/>
           </a:bodyPr>
           <a:lstStyle/>
           <a:p>
@@ -9658,8 +9718,8 @@
           <a:noFill/>
         </p:spPr>
         <p:txBody>
-          <a:bodyPr wrap="none" lIns="18288" rIns="18288" tIns="18288" bIns="18288" anchor="t">
-            <a:spAutoFit/>
+          <a:bodyPr wrap="square" lIns="18288" rIns="18288" tIns="18288" bIns="18288" anchor="t">
+            <a:normAutofit/>
           </a:bodyPr>
           <a:lstStyle/>
           <a:p>
@@ -9693,8 +9753,8 @@
           <a:noFill/>
         </p:spPr>
         <p:txBody>
-          <a:bodyPr wrap="none" lIns="18288" rIns="18288" tIns="18288" bIns="18288" anchor="t">
-            <a:spAutoFit/>
+          <a:bodyPr wrap="square" lIns="18288" rIns="18288" tIns="18288" bIns="18288" anchor="t">
+            <a:normAutofit/>
           </a:bodyPr>
           <a:lstStyle/>
           <a:p>
@@ -9773,8 +9833,8 @@
           <a:noFill/>
         </p:spPr>
         <p:txBody>
-          <a:bodyPr wrap="none" lIns="18288" rIns="18288" tIns="18288" bIns="18288" anchor="t">
-            <a:spAutoFit/>
+          <a:bodyPr wrap="square" lIns="18288" rIns="18288" tIns="18288" bIns="18288" anchor="t">
+            <a:normAutofit/>
           </a:bodyPr>
           <a:lstStyle/>
           <a:p>
@@ -9808,8 +9868,8 @@
           <a:noFill/>
         </p:spPr>
         <p:txBody>
-          <a:bodyPr wrap="none" lIns="18288" rIns="18288" tIns="18288" bIns="18288" anchor="t">
-            <a:spAutoFit/>
+          <a:bodyPr wrap="square" lIns="18288" rIns="18288" tIns="18288" bIns="18288" anchor="t">
+            <a:normAutofit/>
           </a:bodyPr>
           <a:lstStyle/>
           <a:p>
@@ -9904,8 +9964,8 @@
           <a:noFill/>
         </p:spPr>
         <p:txBody>
-          <a:bodyPr wrap="none" lIns="18288" rIns="18288" tIns="18288" bIns="18288" anchor="t">
-            <a:spAutoFit/>
+          <a:bodyPr wrap="square" lIns="18288" rIns="18288" tIns="18288" bIns="18288" anchor="t">
+            <a:normAutofit/>
           </a:bodyPr>
           <a:lstStyle/>
           <a:p>
@@ -9963,8 +10023,8 @@
           <a:noFill/>
         </p:spPr>
         <p:txBody>
-          <a:bodyPr wrap="none" lIns="18288" rIns="18288" tIns="18288" bIns="18288" anchor="t">
-            <a:spAutoFit/>
+          <a:bodyPr wrap="square" lIns="18288" rIns="18288" tIns="18288" bIns="18288" anchor="t">
+            <a:normAutofit/>
           </a:bodyPr>
           <a:lstStyle/>
           <a:p>
@@ -10034,29 +10094,30 @@
         </p:nvSpPr>
         <p:spPr>
           <a:xfrm>
-            <a:off x="914400" y="1581912"/>
-            <a:ext cx="2697480" cy="228600"/>
-          </a:xfrm>
-          <a:prstGeom prst="rect">
-            <a:avLst/>
-          </a:prstGeom>
-          <a:noFill/>
-        </p:spPr>
-        <p:txBody>
-          <a:bodyPr wrap="none" lIns="18288" rIns="18288" tIns="18288" bIns="18288" anchor="t">
-            <a:spAutoFit/>
+            <a:off x="914400" y="1527048"/>
+            <a:ext cx="2697480" cy="393192"/>
+          </a:xfrm>
+          <a:prstGeom prst="rect">
+            <a:avLst/>
+          </a:prstGeom>
+          <a:noFill/>
+        </p:spPr>
+        <p:txBody>
+          <a:bodyPr wrap="square" lIns="18288" rIns="18288" tIns="18288" bIns="18288" anchor="t">
+            <a:normAutofit/>
           </a:bodyPr>
           <a:lstStyle/>
           <a:p>
             <a:pPr algn="l"/>
             <a:r>
-              <a:rPr sz="1050" b="1">
+              <a:rPr sz="880" b="1">
                 <a:solidFill>
                   <a:srgbClr val="FF5A1F"/>
                 </a:solidFill>
                 <a:latin typeface="Aptos"/>
               </a:rPr>
-              <a:t>SAAS_STIAS_OOB_A</a:t>
+              <a:t>SAAS_STIAS_
+OOB_A</a:t>
             </a:r>
           </a:p>
         </p:txBody>
@@ -10069,23 +10130,23 @@
         </p:nvSpPr>
         <p:spPr>
           <a:xfrm>
-            <a:off x="914400" y="1901952"/>
-            <a:ext cx="2880360" cy="274320"/>
-          </a:xfrm>
-          <a:prstGeom prst="rect">
-            <a:avLst/>
-          </a:prstGeom>
-          <a:noFill/>
-        </p:spPr>
-        <p:txBody>
-          <a:bodyPr wrap="none" lIns="18288" rIns="18288" tIns="18288" bIns="18288" anchor="t">
-            <a:spAutoFit/>
+            <a:off x="914400" y="1947672"/>
+            <a:ext cx="2880360" cy="310896"/>
+          </a:xfrm>
+          <a:prstGeom prst="rect">
+            <a:avLst/>
+          </a:prstGeom>
+          <a:noFill/>
+        </p:spPr>
+        <p:txBody>
+          <a:bodyPr wrap="square" lIns="18288" rIns="18288" tIns="18288" bIns="18288" anchor="t">
+            <a:normAutofit/>
           </a:bodyPr>
           <a:lstStyle/>
           <a:p>
             <a:pPr algn="l"/>
             <a:r>
-              <a:rPr sz="1250" b="1">
+              <a:rPr sz="1120" b="1">
                 <a:solidFill>
                   <a:srgbClr val="1B1648"/>
                 </a:solidFill>
@@ -10113,8 +10174,8 @@
           <a:noFill/>
         </p:spPr>
         <p:txBody>
-          <a:bodyPr wrap="none" lIns="18288" rIns="18288" tIns="18288" bIns="18288" anchor="t">
-            <a:spAutoFit/>
+          <a:bodyPr wrap="square" lIns="18288" rIns="18288" tIns="18288" bIns="18288" anchor="t">
+            <a:normAutofit/>
           </a:bodyPr>
           <a:lstStyle/>
           <a:p>
@@ -10184,23 +10245,23 @@
         </p:nvSpPr>
         <p:spPr>
           <a:xfrm>
-            <a:off x="6446520" y="1581912"/>
-            <a:ext cx="2697480" cy="228600"/>
-          </a:xfrm>
-          <a:prstGeom prst="rect">
-            <a:avLst/>
-          </a:prstGeom>
-          <a:noFill/>
-        </p:spPr>
-        <p:txBody>
-          <a:bodyPr wrap="none" lIns="18288" rIns="18288" tIns="18288" bIns="18288" anchor="t">
-            <a:spAutoFit/>
+            <a:off x="6446520" y="1527048"/>
+            <a:ext cx="2697480" cy="393192"/>
+          </a:xfrm>
+          <a:prstGeom prst="rect">
+            <a:avLst/>
+          </a:prstGeom>
+          <a:noFill/>
+        </p:spPr>
+        <p:txBody>
+          <a:bodyPr wrap="square" lIns="18288" rIns="18288" tIns="18288" bIns="18288" anchor="t">
+            <a:normAutofit/>
           </a:bodyPr>
           <a:lstStyle/>
           <a:p>
             <a:pPr algn="l"/>
             <a:r>
-              <a:rPr sz="1050" b="1">
+              <a:rPr sz="880" b="1">
                 <a:solidFill>
                   <a:srgbClr val="FF5A1F"/>
                 </a:solidFill>
@@ -10219,23 +10280,23 @@
         </p:nvSpPr>
         <p:spPr>
           <a:xfrm>
-            <a:off x="6446520" y="1901952"/>
-            <a:ext cx="2880360" cy="274320"/>
-          </a:xfrm>
-          <a:prstGeom prst="rect">
-            <a:avLst/>
-          </a:prstGeom>
-          <a:noFill/>
-        </p:spPr>
-        <p:txBody>
-          <a:bodyPr wrap="none" lIns="18288" rIns="18288" tIns="18288" bIns="18288" anchor="t">
-            <a:spAutoFit/>
+            <a:off x="6446520" y="1947672"/>
+            <a:ext cx="2880360" cy="310896"/>
+          </a:xfrm>
+          <a:prstGeom prst="rect">
+            <a:avLst/>
+          </a:prstGeom>
+          <a:noFill/>
+        </p:spPr>
+        <p:txBody>
+          <a:bodyPr wrap="square" lIns="18288" rIns="18288" tIns="18288" bIns="18288" anchor="t">
+            <a:normAutofit/>
           </a:bodyPr>
           <a:lstStyle/>
           <a:p>
             <a:pPr algn="l"/>
             <a:r>
-              <a:rPr sz="1250" b="1">
+              <a:rPr sz="1120" b="1">
                 <a:solidFill>
                   <a:srgbClr val="1B1648"/>
                 </a:solidFill>
@@ -10263,8 +10324,8 @@
           <a:noFill/>
         </p:spPr>
         <p:txBody>
-          <a:bodyPr wrap="none" lIns="18288" rIns="18288" tIns="18288" bIns="18288" anchor="t">
-            <a:spAutoFit/>
+          <a:bodyPr wrap="square" lIns="18288" rIns="18288" tIns="18288" bIns="18288" anchor="t">
+            <a:normAutofit/>
           </a:bodyPr>
           <a:lstStyle/>
           <a:p>
@@ -10334,29 +10395,30 @@
         </p:nvSpPr>
         <p:spPr>
           <a:xfrm>
-            <a:off x="914400" y="2999232"/>
-            <a:ext cx="2697480" cy="228600"/>
-          </a:xfrm>
-          <a:prstGeom prst="rect">
-            <a:avLst/>
-          </a:prstGeom>
-          <a:noFill/>
-        </p:spPr>
-        <p:txBody>
-          <a:bodyPr wrap="none" lIns="18288" rIns="18288" tIns="18288" bIns="18288" anchor="t">
-            <a:spAutoFit/>
+            <a:off x="914400" y="2944368"/>
+            <a:ext cx="2697480" cy="393192"/>
+          </a:xfrm>
+          <a:prstGeom prst="rect">
+            <a:avLst/>
+          </a:prstGeom>
+          <a:noFill/>
+        </p:spPr>
+        <p:txBody>
+          <a:bodyPr wrap="square" lIns="18288" rIns="18288" tIns="18288" bIns="18288" anchor="t">
+            <a:normAutofit/>
           </a:bodyPr>
           <a:lstStyle/>
           <a:p>
             <a:pPr algn="l"/>
             <a:r>
-              <a:rPr sz="1050" b="1">
+              <a:rPr sz="880" b="1">
                 <a:solidFill>
                   <a:srgbClr val="FF5A1F"/>
                 </a:solidFill>
                 <a:latin typeface="Aptos"/>
               </a:rPr>
-              <a:t>ZT_STIAS_PROSBC_CLIENT_A</a:t>
+              <a:t>ZT_STIAS_PROSBC_
+CLIENT_A</a:t>
             </a:r>
           </a:p>
         </p:txBody>
@@ -10369,23 +10431,23 @@
         </p:nvSpPr>
         <p:spPr>
           <a:xfrm>
-            <a:off x="914400" y="3319272"/>
-            <a:ext cx="2880360" cy="274320"/>
-          </a:xfrm>
-          <a:prstGeom prst="rect">
-            <a:avLst/>
-          </a:prstGeom>
-          <a:noFill/>
-        </p:spPr>
-        <p:txBody>
-          <a:bodyPr wrap="none" lIns="18288" rIns="18288" tIns="18288" bIns="18288" anchor="t">
-            <a:spAutoFit/>
+            <a:off x="914400" y="3364992"/>
+            <a:ext cx="2880360" cy="310896"/>
+          </a:xfrm>
+          <a:prstGeom prst="rect">
+            <a:avLst/>
+          </a:prstGeom>
+          <a:noFill/>
+        </p:spPr>
+        <p:txBody>
+          <a:bodyPr wrap="square" lIns="18288" rIns="18288" tIns="18288" bIns="18288" anchor="t">
+            <a:normAutofit/>
           </a:bodyPr>
           <a:lstStyle/>
           <a:p>
             <a:pPr algn="l"/>
             <a:r>
-              <a:rPr sz="1250" b="1">
+              <a:rPr sz="1120" b="1">
                 <a:solidFill>
                   <a:srgbClr val="1B1648"/>
                 </a:solidFill>
@@ -10413,8 +10475,8 @@
           <a:noFill/>
         </p:spPr>
         <p:txBody>
-          <a:bodyPr wrap="none" lIns="18288" rIns="18288" tIns="18288" bIns="18288" anchor="t">
-            <a:spAutoFit/>
+          <a:bodyPr wrap="square" lIns="18288" rIns="18288" tIns="18288" bIns="18288" anchor="t">
+            <a:normAutofit/>
           </a:bodyPr>
           <a:lstStyle/>
           <a:p>
@@ -10484,29 +10546,30 @@
         </p:nvSpPr>
         <p:spPr>
           <a:xfrm>
-            <a:off x="6446520" y="2999232"/>
-            <a:ext cx="2697480" cy="228600"/>
-          </a:xfrm>
-          <a:prstGeom prst="rect">
-            <a:avLst/>
-          </a:prstGeom>
-          <a:noFill/>
-        </p:spPr>
-        <p:txBody>
-          <a:bodyPr wrap="none" lIns="18288" rIns="18288" tIns="18288" bIns="18288" anchor="t">
-            <a:spAutoFit/>
+            <a:off x="6446520" y="2944368"/>
+            <a:ext cx="2697480" cy="393192"/>
+          </a:xfrm>
+          <a:prstGeom prst="rect">
+            <a:avLst/>
+          </a:prstGeom>
+          <a:noFill/>
+        </p:spPr>
+        <p:txBody>
+          <a:bodyPr wrap="square" lIns="18288" rIns="18288" tIns="18288" bIns="18288" anchor="t">
+            <a:normAutofit/>
           </a:bodyPr>
           <a:lstStyle/>
           <a:p>
             <a:pPr algn="l"/>
             <a:r>
-              <a:rPr sz="1050" b="1">
+              <a:rPr sz="880" b="1">
                 <a:solidFill>
                   <a:srgbClr val="FF5A1F"/>
                 </a:solidFill>
                 <a:latin typeface="Aptos"/>
               </a:rPr>
-              <a:t>ZT_STIAS_PROSBC_SETUP_CLIENT_A</a:t>
+              <a:t>ZT_STIAS_PROSBC_
+SETUP_CLIENT_A</a:t>
             </a:r>
           </a:p>
         </p:txBody>
@@ -10519,23 +10582,23 @@
         </p:nvSpPr>
         <p:spPr>
           <a:xfrm>
-            <a:off x="6446520" y="3319272"/>
-            <a:ext cx="2880360" cy="274320"/>
-          </a:xfrm>
-          <a:prstGeom prst="rect">
-            <a:avLst/>
-          </a:prstGeom>
-          <a:noFill/>
-        </p:spPr>
-        <p:txBody>
-          <a:bodyPr wrap="none" lIns="18288" rIns="18288" tIns="18288" bIns="18288" anchor="t">
-            <a:spAutoFit/>
+            <a:off x="6446520" y="3364992"/>
+            <a:ext cx="2880360" cy="310896"/>
+          </a:xfrm>
+          <a:prstGeom prst="rect">
+            <a:avLst/>
+          </a:prstGeom>
+          <a:noFill/>
+        </p:spPr>
+        <p:txBody>
+          <a:bodyPr wrap="square" lIns="18288" rIns="18288" tIns="18288" bIns="18288" anchor="t">
+            <a:normAutofit/>
           </a:bodyPr>
           <a:lstStyle/>
           <a:p>
             <a:pPr algn="l"/>
             <a:r>
-              <a:rPr sz="1250" b="1">
+              <a:rPr sz="1120" b="1">
                 <a:solidFill>
                   <a:srgbClr val="1B1648"/>
                 </a:solidFill>
@@ -10563,8 +10626,8 @@
           <a:noFill/>
         </p:spPr>
         <p:txBody>
-          <a:bodyPr wrap="none" lIns="18288" rIns="18288" tIns="18288" bIns="18288" anchor="t">
-            <a:spAutoFit/>
+          <a:bodyPr wrap="square" lIns="18288" rIns="18288" tIns="18288" bIns="18288" anchor="t">
+            <a:normAutofit/>
           </a:bodyPr>
           <a:lstStyle/>
           <a:p>
@@ -10634,29 +10697,30 @@
         </p:nvSpPr>
         <p:spPr>
           <a:xfrm>
-            <a:off x="914400" y="4416552"/>
-            <a:ext cx="2697480" cy="228600"/>
-          </a:xfrm>
-          <a:prstGeom prst="rect">
-            <a:avLst/>
-          </a:prstGeom>
-          <a:noFill/>
-        </p:spPr>
-        <p:txBody>
-          <a:bodyPr wrap="none" lIns="18288" rIns="18288" tIns="18288" bIns="18288" anchor="t">
-            <a:spAutoFit/>
+            <a:off x="914400" y="4361688"/>
+            <a:ext cx="2697480" cy="393192"/>
+          </a:xfrm>
+          <a:prstGeom prst="rect">
+            <a:avLst/>
+          </a:prstGeom>
+          <a:noFill/>
+        </p:spPr>
+        <p:txBody>
+          <a:bodyPr wrap="square" lIns="18288" rIns="18288" tIns="18288" bIns="18288" anchor="t">
+            <a:normAutofit/>
           </a:bodyPr>
           <a:lstStyle/>
           <a:p>
             <a:pPr algn="l"/>
             <a:r>
-              <a:rPr sz="1050" b="1">
+              <a:rPr sz="880" b="1">
                 <a:solidFill>
                   <a:srgbClr val="FF5A1F"/>
                 </a:solidFill>
                 <a:latin typeface="Aptos"/>
               </a:rPr>
-              <a:t>ZT_PROSBC_HW500_STIAS_SETUP_CLIENT_A</a:t>
+              <a:t>ZT_PROSBC_HW500_
+STIAS_SETUP_CLIENT_A</a:t>
             </a:r>
           </a:p>
         </p:txBody>
@@ -10669,23 +10733,23 @@
         </p:nvSpPr>
         <p:spPr>
           <a:xfrm>
-            <a:off x="914400" y="4736592"/>
-            <a:ext cx="2880360" cy="274320"/>
-          </a:xfrm>
-          <a:prstGeom prst="rect">
-            <a:avLst/>
-          </a:prstGeom>
-          <a:noFill/>
-        </p:spPr>
-        <p:txBody>
-          <a:bodyPr wrap="none" lIns="18288" rIns="18288" tIns="18288" bIns="18288" anchor="t">
-            <a:spAutoFit/>
+            <a:off x="914400" y="4782312"/>
+            <a:ext cx="2880360" cy="310896"/>
+          </a:xfrm>
+          <a:prstGeom prst="rect">
+            <a:avLst/>
+          </a:prstGeom>
+          <a:noFill/>
+        </p:spPr>
+        <p:txBody>
+          <a:bodyPr wrap="square" lIns="18288" rIns="18288" tIns="18288" bIns="18288" anchor="t">
+            <a:normAutofit/>
           </a:bodyPr>
           <a:lstStyle/>
           <a:p>
             <a:pPr algn="l"/>
             <a:r>
-              <a:rPr sz="1250" b="1">
+              <a:rPr sz="1120" b="1">
                 <a:solidFill>
                   <a:srgbClr val="1B1648"/>
                 </a:solidFill>
@@ -10713,8 +10777,8 @@
           <a:noFill/>
         </p:spPr>
         <p:txBody>
-          <a:bodyPr wrap="none" lIns="18288" rIns="18288" tIns="18288" bIns="18288" anchor="t">
-            <a:spAutoFit/>
+          <a:bodyPr wrap="square" lIns="18288" rIns="18288" tIns="18288" bIns="18288" anchor="t">
+            <a:normAutofit/>
           </a:bodyPr>
           <a:lstStyle/>
           <a:p>
@@ -10784,29 +10848,30 @@
         </p:nvSpPr>
         <p:spPr>
           <a:xfrm>
-            <a:off x="6446520" y="4416552"/>
-            <a:ext cx="2697480" cy="228600"/>
-          </a:xfrm>
-          <a:prstGeom prst="rect">
-            <a:avLst/>
-          </a:prstGeom>
-          <a:noFill/>
-        </p:spPr>
-        <p:txBody>
-          <a:bodyPr wrap="none" lIns="18288" rIns="18288" tIns="18288" bIns="18288" anchor="t">
-            <a:spAutoFit/>
+            <a:off x="6446520" y="4361688"/>
+            <a:ext cx="2697480" cy="393192"/>
+          </a:xfrm>
+          <a:prstGeom prst="rect">
+            <a:avLst/>
+          </a:prstGeom>
+          <a:noFill/>
+        </p:spPr>
+        <p:txBody>
+          <a:bodyPr wrap="square" lIns="18288" rIns="18288" tIns="18288" bIns="18288" anchor="t">
+            <a:normAutofit/>
           </a:bodyPr>
           <a:lstStyle/>
           <a:p>
             <a:pPr algn="l"/>
             <a:r>
-              <a:rPr sz="1050" b="1">
+              <a:rPr sz="880" b="1">
                 <a:solidFill>
                   <a:srgbClr val="FF5A1F"/>
                 </a:solidFill>
                 <a:latin typeface="Aptos"/>
               </a:rPr>
-              <a:t>ZT_PROSBC_HW500_STIAS_HYBRID_API_A</a:t>
+              <a:t>ZT_PROSBC_HW500_
+STIAS_HYBRID_API_A</a:t>
             </a:r>
           </a:p>
         </p:txBody>
@@ -10819,23 +10884,23 @@
         </p:nvSpPr>
         <p:spPr>
           <a:xfrm>
-            <a:off x="6446520" y="4736592"/>
-            <a:ext cx="2880360" cy="274320"/>
-          </a:xfrm>
-          <a:prstGeom prst="rect">
-            <a:avLst/>
-          </a:prstGeom>
-          <a:noFill/>
-        </p:spPr>
-        <p:txBody>
-          <a:bodyPr wrap="none" lIns="18288" rIns="18288" tIns="18288" bIns="18288" anchor="t">
-            <a:spAutoFit/>
+            <a:off x="6446520" y="4782312"/>
+            <a:ext cx="2880360" cy="310896"/>
+          </a:xfrm>
+          <a:prstGeom prst="rect">
+            <a:avLst/>
+          </a:prstGeom>
+          <a:noFill/>
+        </p:spPr>
+        <p:txBody>
+          <a:bodyPr wrap="square" lIns="18288" rIns="18288" tIns="18288" bIns="18288" anchor="t">
+            <a:normAutofit/>
           </a:bodyPr>
           <a:lstStyle/>
           <a:p>
             <a:pPr algn="l"/>
             <a:r>
-              <a:rPr sz="1250" b="1">
+              <a:rPr sz="1120" b="1">
                 <a:solidFill>
                   <a:srgbClr val="1B1648"/>
                 </a:solidFill>
@@ -10863,8 +10928,8 @@
           <a:noFill/>
         </p:spPr>
         <p:txBody>
-          <a:bodyPr wrap="none" lIns="18288" rIns="18288" tIns="18288" bIns="18288" anchor="t">
-            <a:spAutoFit/>
+          <a:bodyPr wrap="square" lIns="18288" rIns="18288" tIns="18288" bIns="18288" anchor="t">
+            <a:normAutofit/>
           </a:bodyPr>
           <a:lstStyle/>
           <a:p>
@@ -10898,8 +10963,8 @@
           <a:noFill/>
         </p:spPr>
         <p:txBody>
-          <a:bodyPr wrap="none" lIns="18288" rIns="18288" tIns="18288" bIns="18288" anchor="t">
-            <a:spAutoFit/>
+          <a:bodyPr wrap="square" lIns="18288" rIns="18288" tIns="18288" bIns="18288" anchor="t">
+            <a:normAutofit/>
           </a:bodyPr>
           <a:lstStyle/>
           <a:p>

</xml_diff>